<commit_message>
Record completed AppWorld results and update meeting decks
- v5_results.md/.html: AppWorld TGC/SGC filled for all four conditions;
  native-bridge r2 rerun documented
- Dreaddit analysis and ACE introduction decks reflect the AppWorld outcome
  (offline ACE beats ReAct; gains a third of the paper's)

Co-Authored-By: Claude Opus 5 <noreply@anthropic.com>
</commit_message>
<xml_diff>
--- a/ACL 2027/Storage/meeting_20260915/ace_introduction_explained.pptx
+++ b/ACL 2027/Storage/meeting_20260915/ace_introduction_explained.pptx
@@ -11542,7 +11542,7 @@
                 <a:ea typeface="Apple SD Gothic Neo"/>
                 <a:cs typeface="Calibri"/>
               </a:rPr>
-              <a:t>Internal working observations from our v5 panel and the ongoing AppWorld reproduction; not manuscript evidence</a:t>
+              <a:t>Internal working observations from our v5 panel and the AppWorld reproduction, both complete; not manuscript evidence</a:t>
             </a:r>
           </a:p>
         </p:txBody>
@@ -11905,7 +11905,7 @@
                           <a:ea typeface="Apple SD Gothic Neo"/>
                           <a:cs typeface="Calibri"/>
                         </a:rPr>
-                        <a:t>AppWorld reproduction with only the model swapped to Qwen3-8B is running; offline playbooks are growing.</a:t>
+                        <a:t>AppWorld with only the model swapped: offline ACE beats ReAct on test-normal (TGC 22.0 vs 17.9, SGC 10.7 vs 3.6), but the gain is a third of the paper’s and every score is far below it.</a:t>
                       </a:r>
                     </a:p>
                   </a:txBody>
@@ -11929,13 +11929,13 @@
                           <a:ea typeface="Apple SD Gothic Neo"/>
                           <a:cs typeface="Calibri"/>
                         </a:rPr>
-                        <a:t>Running</a:t>
+                        <a:t>Partly</a:t>
                       </a:r>
                     </a:p>
                   </a:txBody>
                   <a:tcPr marL="109728" marR="109728" marT="36576" marB="36576" anchor="ctr">
                     <a:solidFill>
-                      <a:srgbClr val="F1F4F6"/>
+                      <a:srgbClr val="FBE3E6"/>
                     </a:solidFill>
                   </a:tcPr>
                 </a:tc>
@@ -12133,7 +12133,7 @@
                 <a:ea typeface="Apple SD Gothic Neo"/>
                 <a:cs typeface="Calibri"/>
               </a:rPr>
-              <a:t>With an 8B model the headline claims mostly hold on Dreaddit, but the playbooks do not look like the organized, multi-section documents the paper describes. That gap (organization and deduplication) is where a smaller backbone seems to differ, and AppWorld will show whether the agent results carry over.</a:t>
+              <a:t>With an 8B model the direction of the headline claims holds on both benchmarks — ACE beats its baselines, and labels are not required — but the size of the gains does not, and a strong prompt optimizer (GEPA) comes close on Dreaddit. In both cases the playbooks look nothing like the organized, multi-section documents the paper describes: one section absorbs everything and duplicates pile up. Organization and deduplication are where a smaller backbone seems to differ.</a:t>
             </a:r>
           </a:p>
         </p:txBody>

</xml_diff>